<commit_message>
wip: partial implementation interrupted (machine crash)
Work in progress. NOT yet verified: it may not type-check or pass tests. Continue from this state.

Co-Authored-By: Claude Opus 5 <noreply@anthropic.com>
</commit_message>
<xml_diff>
--- a/tests/e2e/fixtures/sample.pptx
+++ b/tests/e2e/fixtures/sample.pptx
@@ -4,6 +4,7 @@
   <p:sldSz cx="12192000" cy="6858000"/>
   <p:sldIdLst>
     <p:sldId id="256" r:id="rId1"/>
+    <p:sldId id="257" r:id="rId2"/>
   </p:sldIdLst>
 </p:presentation>
 </file>
@@ -26,4 +27,24 @@
     </p:spTree>
   </p:cSld>
 </p:sld>
+</file>
+
+<file path=ppt/slides/slide2.xml><?xml version="1.0" encoding="utf-8"?>
+<p:sld xmlns:a="http://schemas.openxmlformats.org/drawingml/2006/main" xmlns:r="http://schemas.openxmlformats.org/officeDocument/2006/relationships" xmlns:p="http://schemas.openxmlformats.org/presentationml/2006/main">
+  <p:cSld>
+    <p:spTree>
+      <p:sp>
+        <p:txBody>
+          <a:bodyPr/>
+          <a:lstStyle/>
+          <a:p>
+            <a:r>
+              <a:t>Second PPTX slide</a:t>
+            </a:r>
+          </a:p>
+        </p:txBody>
+      </p:sp>
+    </p:spTree>
+  </p:cSld>
+</p:sld>
 </file>
</xml_diff>